<commit_message>
Enhance briefing generation and architecture figures with dynamic data; update pitch deck for consistency
</commit_message>
<xml_diff>
--- a/parksight/reports/out/ParkSight_Pitch_Deck.pptx
+++ b/parksight/reports/out/ParkSight_Pitch_Deck.pptx
@@ -4690,7 +4690,7 @@
                 </a:solidFill>
                 <a:latin typeface="Segoe UI"/>
               </a:rPr>
-              <a:t>•  After converting timestamps UTC→IST, records collapse during 15:00–24:00.</a:t>
+              <a:t>•  After converting timestamps UTC→IST, records collapse during 15:00-24:00 IST.</a:t>
             </a:r>
           </a:p>
           <a:p>
@@ -4870,7 +4870,7 @@
                 </a:solidFill>
                 <a:latin typeface="Segoe UI"/>
               </a:rPr>
-              <a:t>298,450 violations — a near-perfect fit</a:t>
+              <a:t>298,445 violations — a near-perfect fit</a:t>
             </a:r>
           </a:p>
         </p:txBody>

</xml_diff>